<commit_message>
Reframe step 2 of the slides as conversion, not prediction
Step 2 is not about predicting delay at a global variation point. It
converts a cell-level aggregate value into per-transistor values so that
a per-transistor consumer such as LLE DM has something to multiply its
per-transistor parameter shift against.

- step 2 renamed "TR별 값으로 환산"; input is the aggregate change, output
  is the per-transistor value usable at transistor granularity
- slide 1 and 3 titles and lead lines rewritten around that conversion and
  its destination
- "코너" replaced with "전역 변동점" / "전역 파라미터 이동" on slide 5, since
  a corner is one vertex of the parameter space rather than the general
  evaluation point

Co-Authored-By: Claude Opus 5 <noreply@anthropic.com>
Claude-Session: https://claude.ai/code/session_01SyCnFqwRQVGwkpWsx5LduK
</commit_message>
<xml_diff>
--- a/lvf_global_var/doc/slides/invention_4steps.pptx
+++ b/lvf_global_var/doc/slides/invention_4steps.pptx
@@ -3827,7 +3827,7 @@
                 <a:latin typeface="Malgun Gothic"/>
                 <a:ea typeface="Malgun Gothic"/>
               </a:rPr>
-              <a:t>TR 기여도 × USM 결합으로 재특성화 없이 변동 반영</a:t>
+              <a:t>기여도로 집합값을 TR 단위로 환산해 LLE DM에 연결</a:t>
             </a:r>
           </a:p>
         </p:txBody>
@@ -3867,7 +3867,7 @@
                 <a:latin typeface="Malgun Gothic"/>
                 <a:ea typeface="Malgun Gothic"/>
               </a:rPr>
-              <a:t>LVF 특성화 결과를 재사용하여 트랜지스터별 민감도를 복원하고, 모든 변동 원인을 하나의 식으로 처리한다.</a:t>
+              <a:t>셀 단위로만 주어지는 집합값을 기여도로 트랜지스터 단위로 환산하여, 트랜지스터별 변동량을 쓰는 LLE DM에 연결한다.</a:t>
             </a:r>
           </a:p>
         </p:txBody>
@@ -4332,7 +4332,7 @@
                 <a:latin typeface="Malgun Gothic"/>
                 <a:ea typeface="Malgun Gothic"/>
               </a:rPr>
-              <a:t>TR별 민감도 복원</a:t>
+              <a:t>TR별 값으로 환산</a:t>
             </a:r>
           </a:p>
         </p:txBody>
@@ -4411,7 +4411,7 @@
                 <a:latin typeface="Malgun Gothic"/>
                 <a:ea typeface="Malgun Gothic"/>
               </a:rPr>
-              <a:t>USM 라이브러리의 집합 민감도</a:t>
+              <a:t>USM 라이브러리의 집합 변화량</a:t>
             </a:r>
           </a:p>
           <a:p>
@@ -4428,7 +4428,7 @@
                 <a:latin typeface="Malgun Gothic"/>
                 <a:ea typeface="Malgun Gothic"/>
               </a:rPr>
-              <a:t>S_agg(p)</a:t>
+              <a:t>셀 전체를 함께 흔든 결과</a:t>
             </a:r>
           </a:p>
         </p:txBody>
@@ -4507,7 +4507,7 @@
                 <a:latin typeface="Consolas"/>
                 <a:ea typeface="Malgun Gothic"/>
               </a:rPr>
-              <a:t>S_rec(i, p) = C(i) · S_agg(p)</a:t>
+              <a:t>TR별 값 = C(i) × 집합값</a:t>
             </a:r>
           </a:p>
         </p:txBody>
@@ -4586,7 +4586,7 @@
                 <a:latin typeface="Malgun Gothic"/>
                 <a:ea typeface="Malgun Gothic"/>
               </a:rPr>
-              <a:t>TR별 파라미터 민감도</a:t>
+              <a:t>TR별 민감도 / 변동량</a:t>
             </a:r>
           </a:p>
           <a:p>
@@ -4603,7 +4603,7 @@
                 <a:latin typeface="Malgun Gothic"/>
                 <a:ea typeface="Malgun Gothic"/>
               </a:rPr>
-              <a:t>전역 변동 예측에 사용</a:t>
+              <a:t>TR 단위로 사용 가능</a:t>
             </a:r>
           </a:p>
         </p:txBody>
@@ -5454,7 +5454,7 @@
                 <a:latin typeface="Malgun Gothic"/>
                 <a:ea typeface="Malgun Gothic"/>
               </a:rPr>
-              <a:t>개별 TR 특성화 시뮬레이션 추가 없음. 새로운 변동 원인은 Δp(i, p)만 교체하면 동일 경로로 처리된다.</a:t>
+              <a:t>개별 TR 특성화 시뮬레이션 추가 없음. LLE, 전역 파라미터 이동, 열화가 Δp(i, p)만 바꾸어 같은 경로로 들어온다.</a:t>
             </a:r>
           </a:p>
         </p:txBody>
@@ -5942,7 +5942,7 @@
                 <a:latin typeface="Malgun Gothic"/>
                 <a:ea typeface="Malgun Gothic"/>
               </a:rPr>
-              <a:t>부호를 유지하면 복원 오차가 더 작다</a:t>
+              <a:t>부호를 유지하면 환산 오차가 더 작다</a:t>
             </a:r>
           </a:p>
           <a:p>
@@ -6946,7 +6946,7 @@
                 <a:latin typeface="Malgun Gothic"/>
                 <a:ea typeface="Malgun Gothic"/>
               </a:rPr>
-              <a:t>USM에 기여도를 곱하면 TR별로 분해된다</a:t>
+              <a:t>집합값은 기여도를 곱해야 TR 단위가 된다</a:t>
             </a:r>
           </a:p>
         </p:txBody>
@@ -6986,7 +6986,7 @@
                 <a:latin typeface="Malgun Gothic"/>
                 <a:ea typeface="Malgun Gothic"/>
               </a:rPr>
-              <a:t>USM 민감도는 셀 전체를 동시에 섭동한 값이라 TR 식별 정보가 없다. 기여도가 그 정보를 보완한다.</a:t>
+              <a:t>USM 값은 셀 전체를 동시에 섭동한 결과라 TR 식별 정보가 없다. LLE DM은 TR별 Δp를 주는데 받을 상대가 없다.</a:t>
             </a:r>
           </a:p>
         </p:txBody>
@@ -7319,7 +7319,7 @@
                 <a:latin typeface="Malgun Gothic"/>
                 <a:ea typeface="Malgun Gothic"/>
               </a:rPr>
-              <a:t>USM 민감도 S_agg(p)는 셀 전체의 합이다. 트랜지스터별로 나눌 근거가 라이브러리 안에 없다.</a:t>
+              <a:t>USM 값 S_agg(p)는 셀 전체의 합이다. LLE DM이 만든 TR별 Δp를 곱할 TR별 상대가 없다.</a:t>
             </a:r>
           </a:p>
         </p:txBody>
@@ -7381,7 +7381,7 @@
                 <a:latin typeface="Malgun Gothic"/>
                 <a:ea typeface="Malgun Gothic"/>
               </a:rPr>
-              <a:t>해결</a:t>
+              <a:t>환산</a:t>
             </a:r>
           </a:p>
         </p:txBody>
@@ -7607,7 +7607,7 @@
                 <a:latin typeface="Malgun Gothic"/>
                 <a:ea typeface="Malgun Gothic"/>
               </a:rPr>
-              <a:t>복원 정확도 — 그룹 동시 섭동으로 얻은 직접 민감도 대비 (3σ, 지연 대비 %)</a:t>
+              <a:t>환산 정확도 — 그룹 동시 섭동으로 얻은 직접 민감도 대비 (3σ, 지연 대비 %)</a:t>
             </a:r>
           </a:p>
         </p:txBody>
@@ -8305,7 +8305,7 @@
                 <a:latin typeface="Malgun Gothic"/>
                 <a:ea typeface="Malgun Gothic"/>
               </a:rPr>
-              <a:t>정합성 조건을 만족하므로, 동시 변동 시 타이밍 변화량이 개별 TR 변화량의 합과 일치한다.</a:t>
+              <a:t>환산이 정합성 조건을 만족하므로, 모든 TR을 같은 양으로 움직이면 집합값이 그대로 복구된다.</a:t>
             </a:r>
           </a:p>
           <a:p>
@@ -9477,7 +9477,7 @@
                           <a:latin typeface="Malgun Gothic"/>
                           <a:ea typeface="Malgun Gothic"/>
                         </a:rPr>
-                        <a:t>기여도 × 집합 민감도로 복원</a:t>
+                        <a:t>기여도로 집합값을 환산</a:t>
                       </a:r>
                     </a:p>
                   </a:txBody>
@@ -10529,7 +10529,7 @@
                           <a:latin typeface="Malgun Gothic"/>
                           <a:ea typeface="Malgun Gothic"/>
                         </a:rPr>
-                        <a:t>전역 공정 변동</a:t>
+                        <a:t>전역 파라미터 이동</a:t>
                       </a:r>
                     </a:p>
                   </a:txBody>
@@ -10581,7 +10581,7 @@
                           <a:latin typeface="Malgun Gothic"/>
                           <a:ea typeface="Malgun Gothic"/>
                         </a:rPr>
-                        <a:t>공정 코너 정의  ΔVth, ΔU0</a:t>
+                        <a:t>전역 변동점 정의  ΔVth, ΔU0</a:t>
                       </a:r>
                     </a:p>
                   </a:txBody>
@@ -11752,7 +11752,7 @@
                           <a:latin typeface="Malgun Gothic"/>
                           <a:ea typeface="Malgun Gothic"/>
                         </a:rPr>
-                        <a:t>±3σ 복합 코너</a:t>
+                        <a:t>±3σ 복합 변동점</a:t>
                       </a:r>
                     </a:p>
                   </a:txBody>

</xml_diff>